<commit_message>
Add author details and update presentation title slide
Co-Authored-By: Claude Opus 5.5 <noreply@anthropic.com>
</commit_message>
<xml_diff>
--- a/presentation/Customer_Review_Analyzer.pptx
+++ b/presentation/Customer_Review_Analyzer.pptx
@@ -3021,32 +3021,114 @@
         </p:nvSpPr>
         <p:spPr>
           <a:xfrm>
-            <a:off x="457200" y="1463040"/>
-            <a:ext cx="5486400" cy="320040"/>
-          </a:xfrm>
-          <a:prstGeom prst="rect">
-            <a:avLst/>
-          </a:prstGeom>
-          <a:noFill/>
-          <a:ln/>
-        </p:spPr>
-        <p:txBody>
-          <a:bodyPr wrap="square" lIns="0" tIns="0" rIns="0" bIns="0" rtlCol="0" anchor="ctr"/>
-          <a:lstStyle/>
-          <a:p>
-            <a:pPr indent="0" marL="0">
-              <a:buNone/>
-            </a:pPr>
-            <a:r>
-              <a:rPr lang="en-US" sz="1400" b="1" spc="300" kern="0" dirty="0">
-                <a:solidFill>
-                  <a:srgbClr val="FCA311"/>
+            <a:off x="5029200" y="502920"/>
+            <a:ext cx="3657600" cy="777240"/>
+          </a:xfrm>
+          <a:prstGeom prst="rect">
+            <a:avLst/>
+          </a:prstGeom>
+          <a:noFill/>
+          <a:ln/>
+        </p:spPr>
+        <p:txBody>
+          <a:bodyPr wrap="square" lIns="0" tIns="0" rIns="0" bIns="0" rtlCol="0" anchor="t"/>
+          <a:lstStyle/>
+          <a:p>
+            <a:pPr algn="r" indent="0" marL="0">
+              <a:spcAft>
+                <a:spcPts val="200"/>
+              </a:spcAft>
+              <a:buNone/>
+            </a:pPr>
+            <a:r>
+              <a:rPr lang="en-US" sz="1800" b="1" dirty="0">
+                <a:solidFill>
+                  <a:srgbClr val="FFFFFF"/>
                 </a:solidFill>
                 <a:latin typeface="Calibri" pitchFamily="34" charset="0"/>
                 <a:ea typeface="Calibri" pitchFamily="34" charset="-122"/>
                 <a:cs typeface="Calibri" pitchFamily="34" charset="-120"/>
               </a:rPr>
-              <a:t>NLP PROJECT SUBMISSION</a:t>
+              <a:t>Nishka Mishra</a:t>
+            </a:r>
+            <a:endParaRPr lang="en-US" sz="1800" dirty="0"/>
+          </a:p>
+          <a:p>
+            <a:pPr algn="r" indent="0" marL="0">
+              <a:spcAft>
+                <a:spcPts val="200"/>
+              </a:spcAft>
+              <a:buNone/>
+            </a:pPr>
+            <a:r>
+              <a:rPr lang="en-US" sz="1300" dirty="0">
+                <a:solidFill>
+                  <a:srgbClr val="C9D2E3"/>
+                </a:solidFill>
+                <a:latin typeface="Calibri" pitchFamily="34" charset="0"/>
+                <a:ea typeface="Calibri" pitchFamily="34" charset="-122"/>
+                <a:cs typeface="Calibri" pitchFamily="34" charset="-120"/>
+              </a:rPr>
+              <a:t>Reg. No. 23FE10CDS00431</a:t>
+            </a:r>
+            <a:endParaRPr lang="en-US" sz="1800" dirty="0"/>
+          </a:p>
+          <a:p>
+            <a:pPr algn="r" indent="0" marL="0">
+              <a:spcAft>
+                <a:spcPts val="200"/>
+              </a:spcAft>
+              <a:buNone/>
+            </a:pPr>
+            <a:r>
+              <a:rPr lang="en-US" sz="1300" dirty="0">
+                <a:solidFill>
+                  <a:srgbClr val="C9D2E3"/>
+                </a:solidFill>
+                <a:latin typeface="Calibri" pitchFamily="34" charset="0"/>
+                <a:ea typeface="Calibri" pitchFamily="34" charset="-122"/>
+                <a:cs typeface="Calibri" pitchFamily="34" charset="-120"/>
+              </a:rPr>
+              <a:t>Data Science  ·  Batch F</a:t>
+            </a:r>
+            <a:endParaRPr lang="en-US" sz="1800" dirty="0"/>
+          </a:p>
+        </p:txBody>
+      </p:sp>
+      <p:sp>
+        <p:nvSpPr>
+          <p:cNvPr id="5" name="Text 2"/>
+          <p:cNvSpPr txBox="1"/>
+          <p:nvPr/>
+        </p:nvSpPr>
+        <p:spPr>
+          <a:xfrm>
+            <a:off x="457200" y="1463040"/>
+            <a:ext cx="5486400" cy="320040"/>
+          </a:xfrm>
+          <a:prstGeom prst="rect">
+            <a:avLst/>
+          </a:prstGeom>
+          <a:noFill/>
+          <a:ln/>
+        </p:spPr>
+        <p:txBody>
+          <a:bodyPr wrap="square" lIns="0" tIns="0" rIns="0" bIns="0" rtlCol="0" anchor="ctr"/>
+          <a:lstStyle/>
+          <a:p>
+            <a:pPr indent="0" marL="0">
+              <a:buNone/>
+            </a:pPr>
+            <a:r>
+              <a:rPr lang="en-US" sz="1400" b="1" spc="300" kern="0" dirty="0">
+                <a:solidFill>
+                  <a:srgbClr val="FCA311"/>
+                </a:solidFill>
+                <a:latin typeface="Calibri" pitchFamily="34" charset="0"/>
+                <a:ea typeface="Calibri" pitchFamily="34" charset="-122"/>
+                <a:cs typeface="Calibri" pitchFamily="34" charset="-120"/>
+              </a:rPr>
+              <a:t>NLP CAPSTONE PROJECT</a:t>
             </a:r>
             <a:endParaRPr lang="en-US" sz="1400" dirty="0"/>
           </a:p>
@@ -3054,7 +3136,7 @@
       </p:sp>
       <p:sp>
         <p:nvSpPr>
-          <p:cNvPr id="5" name="Text 2"/>
+          <p:cNvPr id="6" name="Text 3"/>
           <p:cNvSpPr txBox="1"/>
           <p:nvPr/>
         </p:nvSpPr>
@@ -3093,7 +3175,7 @@
       </p:sp>
       <p:sp>
         <p:nvSpPr>
-          <p:cNvPr id="6" name="Text 3"/>
+          <p:cNvPr id="7" name="Text 4"/>
           <p:cNvSpPr txBox="1"/>
           <p:nvPr/>
         </p:nvSpPr>
@@ -3132,7 +3214,7 @@
       </p:sp>
       <p:sp>
         <p:nvSpPr>
-          <p:cNvPr id="7" name="Shape 4"/>
+          <p:cNvPr id="8" name="Shape 5"/>
           <p:cNvSpPr/>
           <p:nvPr/>
         </p:nvSpPr>
@@ -3159,7 +3241,7 @@
       </p:sp>
       <p:sp>
         <p:nvSpPr>
-          <p:cNvPr id="8" name="Text 5"/>
+          <p:cNvPr id="9" name="Text 6"/>
           <p:cNvSpPr txBox="1"/>
           <p:nvPr/>
         </p:nvSpPr>
@@ -3198,7 +3280,7 @@
       </p:sp>
       <p:sp>
         <p:nvSpPr>
-          <p:cNvPr id="9" name="Shape 6"/>
+          <p:cNvPr id="10" name="Shape 7"/>
           <p:cNvSpPr/>
           <p:nvPr/>
         </p:nvSpPr>
@@ -3225,7 +3307,7 @@
       </p:sp>
       <p:sp>
         <p:nvSpPr>
-          <p:cNvPr id="10" name="Text 7"/>
+          <p:cNvPr id="11" name="Text 8"/>
           <p:cNvSpPr txBox="1"/>
           <p:nvPr/>
         </p:nvSpPr>
@@ -3264,7 +3346,7 @@
       </p:sp>
       <p:sp>
         <p:nvSpPr>
-          <p:cNvPr id="11" name="Shape 8"/>
+          <p:cNvPr id="12" name="Shape 9"/>
           <p:cNvSpPr/>
           <p:nvPr/>
         </p:nvSpPr>
@@ -3291,7 +3373,7 @@
       </p:sp>
       <p:sp>
         <p:nvSpPr>
-          <p:cNvPr id="12" name="Text 9"/>
+          <p:cNvPr id="13" name="Text 10"/>
           <p:cNvSpPr txBox="1"/>
           <p:nvPr/>
         </p:nvSpPr>
@@ -3330,7 +3412,7 @@
       </p:sp>
       <p:sp>
         <p:nvSpPr>
-          <p:cNvPr id="13" name="Shape 10"/>
+          <p:cNvPr id="14" name="Shape 11"/>
           <p:cNvSpPr/>
           <p:nvPr/>
         </p:nvSpPr>
@@ -3357,7 +3439,7 @@
       </p:sp>
       <p:sp>
         <p:nvSpPr>
-          <p:cNvPr id="14" name="Text 11"/>
+          <p:cNvPr id="15" name="Text 12"/>
           <p:cNvSpPr txBox="1"/>
           <p:nvPr/>
         </p:nvSpPr>
@@ -3396,7 +3478,7 @@
       </p:sp>
       <p:sp>
         <p:nvSpPr>
-          <p:cNvPr id="15" name="Shape 12"/>
+          <p:cNvPr id="16" name="Shape 13"/>
           <p:cNvSpPr/>
           <p:nvPr/>
         </p:nvSpPr>
@@ -3423,7 +3505,7 @@
       </p:sp>
       <p:sp>
         <p:nvSpPr>
-          <p:cNvPr id="16" name="Text 13"/>
+          <p:cNvPr id="17" name="Text 14"/>
           <p:cNvSpPr txBox="1"/>
           <p:nvPr/>
         </p:nvSpPr>
@@ -3462,7 +3544,7 @@
       </p:sp>
       <p:pic>
         <p:nvPicPr>
-          <p:cNvPr id="17" name="Image 1" descr="preencoded.png">    </p:cNvPr>
+          <p:cNvPr id="18" name="Image 1" descr="preencoded.png">    </p:cNvPr>
           <p:cNvPicPr>
             <a:picLocks noChangeAspect="1"/>
           </p:cNvPicPr>
@@ -3486,7 +3568,7 @@
       </p:pic>
       <p:sp>
         <p:nvSpPr>
-          <p:cNvPr id="18" name="Text 14">
+          <p:cNvPr id="19" name="Text 15">
             <a:hlinkClick r:id="rId3" tooltip=""/>
           </p:cNvPr>
           <p:cNvSpPr txBox="1"/>

</xml_diff>

<commit_message>
Add live demo link to README and presentation
Co-Authored-By: Claude Opus 5.5 <noreply@anthropic.com>
</commit_message>
<xml_diff>
--- a/presentation/Customer_Review_Analyzer.pptx
+++ b/presentation/Customer_Review_Analyzer.pptx
@@ -3558,7 +3558,7 @@
         </p:blipFill>
         <p:spPr>
           <a:xfrm>
-            <a:off x="457200" y="4334256"/>
+            <a:off x="457200" y="4087368"/>
             <a:ext cx="237744" cy="237744"/>
           </a:xfrm>
           <a:prstGeom prst="rect">
@@ -3576,7 +3576,7 @@
         </p:nvSpPr>
         <p:spPr>
           <a:xfrm>
-            <a:off x="786384" y="4315968"/>
+            <a:off x="786384" y="4069080"/>
             <a:ext cx="5486400" cy="274320"/>
           </a:xfrm>
           <a:prstGeom prst="rect">
@@ -3609,6 +3609,78 @@
                 </a:hlinkClick>
               </a:rPr>
               <a:t>github.com/nishka155/customer-review-analyzer</a:t>
+            </a:r>
+            <a:endParaRPr lang="en-US" sz="1300" dirty="0"/>
+          </a:p>
+        </p:txBody>
+      </p:sp>
+      <p:pic>
+        <p:nvPicPr>
+          <p:cNvPr id="20" name="Image 2" descr="preencoded.png">    </p:cNvPr>
+          <p:cNvPicPr>
+            <a:picLocks noChangeAspect="1"/>
+          </p:cNvPicPr>
+          <p:nvPr/>
+        </p:nvPicPr>
+        <p:blipFill>
+          <a:blip r:embed="rId4"/>
+          <a:stretch>
+            <a:fillRect/>
+          </a:stretch>
+        </p:blipFill>
+        <p:spPr>
+          <a:xfrm>
+            <a:off x="457200" y="4434840"/>
+            <a:ext cx="237744" cy="237744"/>
+          </a:xfrm>
+          <a:prstGeom prst="rect">
+            <a:avLst/>
+          </a:prstGeom>
+        </p:spPr>
+      </p:pic>
+      <p:sp>
+        <p:nvSpPr>
+          <p:cNvPr id="21" name="Text 16">
+            <a:hlinkClick r:id="rId5" tooltip=""/>
+          </p:cNvPr>
+          <p:cNvSpPr txBox="1"/>
+          <p:nvPr/>
+        </p:nvSpPr>
+        <p:spPr>
+          <a:xfrm>
+            <a:off x="786384" y="4416552"/>
+            <a:ext cx="6400800" cy="274320"/>
+          </a:xfrm>
+          <a:prstGeom prst="rect">
+            <a:avLst/>
+          </a:prstGeom>
+          <a:noFill/>
+          <a:ln/>
+        </p:spPr>
+        <p:txBody>
+          <a:bodyPr wrap="square" lIns="0" tIns="0" rIns="0" bIns="0" rtlCol="0" anchor="ctr"/>
+          <a:lstStyle/>
+          <a:p>
+            <a:pPr indent="0" marL="0">
+              <a:buNone/>
+            </a:pPr>
+            <a:r>
+              <a:rPr lang="en-US" sz="1300" u="sng" dirty="0">
+                <a:solidFill>
+                  <a:srgbClr val="FCA311"/>
+                </a:solidFill>
+                <a:latin typeface="Calibri" pitchFamily="34" charset="0"/>
+                <a:ea typeface="Calibri" pitchFamily="34" charset="-122"/>
+                <a:cs typeface="Calibri" pitchFamily="34" charset="-120"/>
+                <a:hlinkClick r:id="rId5" invalidUrl="" action="" tgtFrame="" tooltip="" history="1" highlightClick="0" endSnd="0">
+                  <a:extLst>
+                    <a:ext uri="{A12FA001-AC4F-418D-AE19-62706E023703}">
+                      <ahyp:hlinkClr xmlns:ahyp="http://schemas.microsoft.com/office/drawing/2018/hyperlinkcolor" val="tx"/>
+                    </a:ext>
+                  </a:extLst>
+                </a:hlinkClick>
+              </a:rPr>
+              <a:t>customer-review-analyzer-mbf4qfczzc4tat82elfx9u.streamlit.app</a:t>
             </a:r>
             <a:endParaRPr lang="en-US" sz="1300" dirty="0"/>
           </a:p>
@@ -5725,7 +5797,7 @@
         </p:blipFill>
         <p:spPr>
           <a:xfrm>
-            <a:off x="457200" y="4315968"/>
+            <a:off x="457200" y="4224528"/>
             <a:ext cx="237744" cy="237744"/>
           </a:xfrm>
           <a:prstGeom prst="rect">
@@ -5743,7 +5815,7 @@
         </p:nvSpPr>
         <p:spPr>
           <a:xfrm>
-            <a:off x="786384" y="4297680"/>
+            <a:off x="786384" y="4206240"/>
             <a:ext cx="5486400" cy="274320"/>
           </a:xfrm>
           <a:prstGeom prst="rect">
@@ -5776,6 +5848,78 @@
                 </a:hlinkClick>
               </a:rPr>
               <a:t>github.com/nishka155/customer-review-analyzer</a:t>
+            </a:r>
+            <a:endParaRPr lang="en-US" sz="1300" dirty="0"/>
+          </a:p>
+        </p:txBody>
+      </p:sp>
+      <p:pic>
+        <p:nvPicPr>
+          <p:cNvPr id="22" name="Image 5" descr="preencoded.png">    </p:cNvPr>
+          <p:cNvPicPr>
+            <a:picLocks noChangeAspect="1"/>
+          </p:cNvPicPr>
+          <p:nvPr/>
+        </p:nvPicPr>
+        <p:blipFill>
+          <a:blip r:embed="rId7"/>
+          <a:stretch>
+            <a:fillRect/>
+          </a:stretch>
+        </p:blipFill>
+        <p:spPr>
+          <a:xfrm>
+            <a:off x="457200" y="4553712"/>
+            <a:ext cx="237744" cy="237744"/>
+          </a:xfrm>
+          <a:prstGeom prst="rect">
+            <a:avLst/>
+          </a:prstGeom>
+        </p:spPr>
+      </p:pic>
+      <p:sp>
+        <p:nvSpPr>
+          <p:cNvPr id="23" name="Text 15">
+            <a:hlinkClick r:id="rId8" tooltip=""/>
+          </p:cNvPr>
+          <p:cNvSpPr txBox="1"/>
+          <p:nvPr/>
+        </p:nvSpPr>
+        <p:spPr>
+          <a:xfrm>
+            <a:off x="786384" y="4535424"/>
+            <a:ext cx="7315200" cy="274320"/>
+          </a:xfrm>
+          <a:prstGeom prst="rect">
+            <a:avLst/>
+          </a:prstGeom>
+          <a:noFill/>
+          <a:ln/>
+        </p:spPr>
+        <p:txBody>
+          <a:bodyPr wrap="square" lIns="0" tIns="0" rIns="0" bIns="0" rtlCol="0" anchor="ctr"/>
+          <a:lstStyle/>
+          <a:p>
+            <a:pPr indent="0" marL="0">
+              <a:buNone/>
+            </a:pPr>
+            <a:r>
+              <a:rPr lang="en-US" sz="1300" u="sng" dirty="0">
+                <a:solidFill>
+                  <a:srgbClr val="FCA311"/>
+                </a:solidFill>
+                <a:latin typeface="Calibri" pitchFamily="34" charset="0"/>
+                <a:ea typeface="Calibri" pitchFamily="34" charset="-122"/>
+                <a:cs typeface="Calibri" pitchFamily="34" charset="-120"/>
+                <a:hlinkClick r:id="rId8" invalidUrl="" action="" tgtFrame="" tooltip="" history="1" highlightClick="0" endSnd="0">
+                  <a:extLst>
+                    <a:ext uri="{A12FA001-AC4F-418D-AE19-62706E023703}">
+                      <ahyp:hlinkClr xmlns:ahyp="http://schemas.microsoft.com/office/drawing/2018/hyperlinkcolor" val="tx"/>
+                    </a:ext>
+                  </a:extLst>
+                </a:hlinkClick>
+              </a:rPr>
+              <a:t>Live demo: customer-review-analyzer-mbf4qfczzc4tat82elfx9u.streamlit.app</a:t>
             </a:r>
             <a:endParaRPr lang="en-US" sz="1300" dirty="0"/>
           </a:p>

</xml_diff>